<commit_message>
Set prices to Rp15.000–25.000 on the site and Robust Design deck
Aren Rp15.000, Jasmine Bean Curd Latte Rp20.000, Matcha Cloud Rp25.000.
Margin, profit and pilot figures recomputed at the lowest price.

Co-Authored-By: Claude Opus 5.5 <noreply@anthropic.com>
Claude-Session: https://claude.ai/code/session_01UtyVzV9b7GAyDUMaymf2cK
</commit_message>
<xml_diff>
--- a/presentasi/Spill_de_Tea_BMC_Robust_Design.pptx
+++ b/presentasi/Spill_de_Tea_BMC_Robust_Design.pptx
@@ -2352,7 +2352,7 @@
                 <a:ea typeface="Calibri" pitchFamily="34" charset="-122"/>
                 <a:cs typeface="Calibri" pitchFamily="34" charset="-120"/>
               </a:rPr>
-              <a:t>Rasa premium harga mahasiswa: Rp13.000–15.000 vs kompetitor Rp25.000–38.000</a:t>
+              <a:t>Rasa premium harga mahasiswa: Rp15.000–25.000 vs kompetitor Rp25.000–38.000</a:t>
             </a:r>
             <a:endParaRPr lang="en-US" sz="1100" dirty="0"/>
           </a:p>
@@ -3400,7 +3400,7 @@
                 <a:ea typeface="Calibri" pitchFamily="34" charset="-122"/>
                 <a:cs typeface="Calibri" pitchFamily="34" charset="-120"/>
               </a:rPr>
-              <a:t>Penjualan per botol: Aren Rp13.000 · Jasmine Bean Curd &amp; Matcha Cloud Rp15.000</a:t>
+              <a:t>Penjualan per botol: Aren Rp15.000 · Jasmine Bean Curd Rp20.000 · Matcha Cloud Rp25.000</a:t>
             </a:r>
             <a:endParaRPr lang="en-US" sz="950" dirty="0"/>
           </a:p>
@@ -3463,7 +3463,7 @@
                 <a:ea typeface="Calibri" pitchFamily="34" charset="-122"/>
                 <a:cs typeface="Calibri" pitchFamily="34" charset="-120"/>
               </a:rPr>
-              <a:t>Margin kotor ± 68% per botol (Aren)</a:t>
+              <a:t>Margin kotor ± 73% per botol (Aren)</a:t>
             </a:r>
             <a:endParaRPr lang="en-US" sz="950" dirty="0"/>
           </a:p>

</xml_diff>